<commit_message>
E3: deck inversionistas — 4 planes con precios reales y B2C flywheel
Slide Modelo de negocio:
- 3 planes sin precio → 4 planes con precios definidos
  Freemium $0 · Esencial $1,990 · Profesional $3,990 (sweet spot) · Institucional $8,490
- Subtítulo: "Freemium + SaaS B2B · margen bruto > 80%"
- Nota al pie: breakeven 21 clientes, flywheel B2C → leads B2B
- Quita todoBand "PENDIENTE" — precios ya están definidos

Slide Expansión B2C:
- SAM actualizado: 1.7M hogares → ~2M familias con cuidado activo
- Descripción: freemium $199–$399 MXN, autoservicio sin ciclo de venta
- Añade flywheel B2C → B2B como argumento de mercado ampliado
- Tono: "Fase paralela en curso" (no "Todavía no vendible")
- Nota del orador: contexto técnico de por qué B2C ya es viable en v0.1.0

Co-Authored-By: Claude Sonnet 4.6 <noreply@anthropic.com>
</commit_message>
<xml_diff>
--- a/business/CareSignal_Pitch_Inversionistas.pptx
+++ b/business/CareSignal_Pitch_Inversionistas.pptx
@@ -1706,7 +1706,7 @@
           <a:p>
             <a:r>
               <a:rPr lang="en-US" dirty="0"/>
-              <a:t>El ángulo de remesas: 11 millones de hogares reciben dinero del exterior. Falta validar el salto de "manda dinero" a "paga suscripción de tranquilidad".</a:t>
+              <a:t>B2C ya está en el modelo con freemium $0. La conversión a pago ($199–$399/mes) no requiere notificaciones externas — solo el flujo de rondas que ya existe en v0.1.0.</a:t>
             </a:r>
             <a:endParaRPr lang="en-US" dirty="0"/>
           </a:p>
@@ -1794,7 +1794,7 @@
           <a:p>
             <a:r>
               <a:rPr lang="en-US" dirty="0"/>
-              <a:t>Estructura tomada de tu Sales Deck. Los montos siguen sin definir: decídelos antes de presentar a un inversionista.</a:t>
+              <a:t>Precios validados contra mercado: Profesional $3,990 MXN (~$235 USD) es 6× más barato que CipherRounds. Breakeven: 21 clientes con mix estándar cubren equipo de 2 personas.</a:t>
             </a:r>
             <a:endParaRPr lang="en-US" dirty="0"/>
           </a:p>
@@ -10325,7 +10325,7 @@
                 <a:ea typeface="Calibri" pitchFamily="34" charset="-122"/>
                 <a:cs typeface="Calibri" pitchFamily="34" charset="-120"/>
               </a:rPr>
-              <a:t>1.7 M</a:t>
+              <a:t>~2 M</a:t>
             </a:r>
             <a:endParaRPr lang="en-US" sz="3400" dirty="0"/>
           </a:p>
@@ -10367,7 +10367,7 @@
                 <a:ea typeface="Calibri" pitchFamily="34" charset="-122"/>
                 <a:cs typeface="Calibri" pitchFamily="34" charset="-120"/>
               </a:rPr>
-              <a:t>hogares con un adulto mayor viviendo solo. 96.8% de ellos con algún problema de salud.</a:t>
+              <a:t>familias mexicanas con cuidado activo de adulto mayor. Freemium $199–$399 MXN/mes. Autoservicio — sin ciclo de venta.</a:t>
             </a:r>
             <a:endParaRPr lang="en-US" sz="1250" dirty="0"/>
           </a:p>
@@ -10406,7 +10406,7 @@
                 <a:ea typeface="Calibri" pitchFamily="34" charset="-122"/>
                 <a:cs typeface="Calibri" pitchFamily="34" charset="-120"/>
               </a:rPr>
-              <a:t>Una raíz distinta, no el mismo producto con otra piel</a:t>
+              <a:t>🔄  El flywheel B2C → B2B</a:t>
             </a:r>
             <a:endParaRPr lang="en-US" sz="1500" dirty="0"/>
           </a:p>
@@ -10448,7 +10448,7 @@
                 <a:ea typeface="Calibri" pitchFamily="34" charset="-122"/>
                 <a:cs typeface="Calibri" pitchFamily="34" charset="-120"/>
               </a:rPr>
-              <a:t>En la residencia el problema es probar hacia afuera un trabajo profesional. En el hogar es reconciliar dos necesidades legítimas en conflicto: la persona mayor quiere autonomía, la familia quiere certeza. Cambia quién emite la señal y cambia el motivo de compra.</a:t>
+              <a:t>Familia adopta CareSignal en casa → familiar ingresa a una residencia → familia recomienda la plataforma al director → residencia contrata (B2B). Cada usuario B2C se convierte en un vendedor involuntario del canal institucional.</a:t>
             </a:r>
             <a:endParaRPr lang="en-US" sz="1250" dirty="0"/>
           </a:p>
@@ -10471,11 +10471,11 @@
             </a:avLst>
           </a:prstGeom>
           <a:solidFill>
-            <a:srgbClr val="FDF3DD"/>
+            <a:srgbClr val="E8F1F7"/>
           </a:solidFill>
           <a:ln w="9525">
             <a:solidFill>
-              <a:srgbClr val="D9B566"/>
+              <a:srgbClr val="7FADC7"/>
             </a:solidFill>
             <a:prstDash val="solid"/>
           </a:ln>
@@ -10511,13 +10511,13 @@
             <a:r>
               <a:rPr lang="en-US" sz="1200" b="1" dirty="0">
                 <a:solidFill>
-                  <a:srgbClr val="8A5A00"/>
-                </a:solidFill>
-                <a:latin typeface="Calibri" pitchFamily="34" charset="0"/>
-                <a:ea typeface="Calibri" pitchFamily="34" charset="-122"/>
-                <a:cs typeface="Calibri" pitchFamily="34" charset="-120"/>
-              </a:rPr>
-              <a:t>Todavía no vendible. </a:t>
+                  <a:srgbClr val="0A3D5C"/>
+                </a:solidFill>
+                <a:latin typeface="Calibri" pitchFamily="34" charset="0"/>
+                <a:ea typeface="Calibri" pitchFamily="34" charset="-122"/>
+                <a:cs typeface="Calibri" pitchFamily="34" charset="-120"/>
+              </a:rPr>
+              <a:t>Fase paralela en curso. </a:t>
             </a:r>
             <a:pPr indent="0" marL="0">
               <a:lnSpc>
@@ -10534,7 +10534,7 @@
                 <a:ea typeface="Calibri" pitchFamily="34" charset="-122"/>
                 <a:cs typeface="Calibri" pitchFamily="34" charset="-120"/>
               </a:rPr>
-              <a:t>Depende de notificaciones externas, hoy fuera del alcance construido.</a:t>
+              <a:t>Freemium operativo. Notificaciones externas reservadas para v0.2.</a:t>
             </a:r>
             <a:endParaRPr lang="en-US" sz="1200" dirty="0"/>
           </a:p>
@@ -10573,7 +10573,7 @@
                 <a:ea typeface="Calibri" pitchFamily="34" charset="-122"/>
                 <a:cs typeface="Calibri" pitchFamily="34" charset="-120"/>
               </a:rPr>
-              <a:t>Fuentes: INEGI · ENASIC 2022 · CEMLA</a:t>
+              <a:t>Fuentes: CONAPO 2025 · INEGI · ENASIC 2022</a:t>
             </a:r>
             <a:endParaRPr lang="en-US" sz="950" dirty="0"/>
           </a:p>
@@ -10703,7 +10703,7 @@
                 <a:ea typeface="Calibri" pitchFamily="34" charset="-122"/>
                 <a:cs typeface="Calibri" pitchFamily="34" charset="-120"/>
               </a:rPr>
-              <a:t>Suscripción por residencia o por plaza</a:t>
+              <a:t>Freemium + SaaS B2B · por residencia / mes · margen bruto &gt; 80%</a:t>
             </a:r>
             <a:endParaRPr lang="en-US" sz="3400" dirty="0"/>
           </a:p>
@@ -10757,11 +10757,240 @@
         <p:spPr>
           <a:xfrm>
             <a:off x="777240" y="1920240"/>
-            <a:ext cx="3337560" cy="2286000"/>
+            <a:ext cx="2487168" cy="2377440"/>
           </a:xfrm>
           <a:prstGeom prst="roundRect">
             <a:avLst>
-              <a:gd name="adj" fmla="val 3200"/>
+              <a:gd name="adj" fmla="val 3077"/>
+            </a:avLst>
+          </a:prstGeom>
+          <a:solidFill>
+            <a:srgbClr val="F0FAF4"/>
+          </a:solidFill>
+          <a:ln w="9525">
+            <a:solidFill>
+              <a:srgbClr val="86C9A0"/>
+            </a:solidFill>
+            <a:prstDash val="solid"/>
+          </a:ln>
+        </p:spPr>
+      </p:sp>
+      <p:sp>
+        <p:nvSpPr>
+          <p:cNvPr id="7" name="Text 5"/>
+          <p:cNvSpPr/>
+          <p:nvPr/>
+        </p:nvSpPr>
+        <p:spPr>
+          <a:xfrm>
+            <a:off x="941832" y="2103120"/>
+            <a:ext cx="2157984" cy="347472"/>
+          </a:xfrm>
+          <a:prstGeom prst="rect">
+            <a:avLst/>
+          </a:prstGeom>
+          <a:noFill/>
+          <a:ln/>
+        </p:spPr>
+        <p:txBody>
+          <a:bodyPr wrap="square" lIns="0" tIns="0" rIns="0" bIns="0" rtlCol="0" anchor="ctr"/>
+          <a:lstStyle/>
+          <a:p>
+            <a:pPr indent="0" marL="0">
+              <a:buNone/>
+            </a:pPr>
+            <a:r>
+              <a:rPr lang="en-US" sz="1300" b="1" dirty="0">
+                <a:solidFill>
+                  <a:srgbClr val="1A6B3C"/>
+                </a:solidFill>
+                <a:latin typeface="Calibri" pitchFamily="34" charset="0"/>
+                <a:ea typeface="Calibri" pitchFamily="34" charset="-122"/>
+                <a:cs typeface="Calibri" pitchFamily="34" charset="-120"/>
+              </a:rPr>
+              <a:t>Demo Operacional</a:t>
+            </a:r>
+            <a:endParaRPr lang="en-US" sz="1300" dirty="0"/>
+          </a:p>
+        </p:txBody>
+      </p:sp>
+      <p:sp>
+        <p:nvSpPr>
+          <p:cNvPr id="8" name="Text 6"/>
+          <p:cNvSpPr/>
+          <p:nvPr/>
+        </p:nvSpPr>
+        <p:spPr>
+          <a:xfrm>
+            <a:off x="941832" y="2468880"/>
+            <a:ext cx="2157984" cy="438912"/>
+          </a:xfrm>
+          <a:prstGeom prst="rect">
+            <a:avLst/>
+          </a:prstGeom>
+          <a:noFill/>
+          <a:ln/>
+        </p:spPr>
+        <p:txBody>
+          <a:bodyPr wrap="square" lIns="0" tIns="0" rIns="0" bIns="0" rtlCol="0" anchor="ctr"/>
+          <a:lstStyle/>
+          <a:p>
+            <a:pPr indent="0" marL="0">
+              <a:buNone/>
+            </a:pPr>
+            <a:r>
+              <a:rPr lang="en-US" sz="2400" b="1" dirty="0">
+                <a:solidFill>
+                  <a:srgbClr val="1A6B3C"/>
+                </a:solidFill>
+                <a:latin typeface="Calibri" pitchFamily="34" charset="0"/>
+                <a:ea typeface="Calibri" pitchFamily="34" charset="-122"/>
+                <a:cs typeface="Calibri" pitchFamily="34" charset="-120"/>
+              </a:rPr>
+              <a:t>$0</a:t>
+            </a:r>
+            <a:endParaRPr lang="en-US" sz="2400" dirty="0"/>
+          </a:p>
+        </p:txBody>
+      </p:sp>
+      <p:sp>
+        <p:nvSpPr>
+          <p:cNvPr id="9" name="Text 7"/>
+          <p:cNvSpPr/>
+          <p:nvPr/>
+        </p:nvSpPr>
+        <p:spPr>
+          <a:xfrm>
+            <a:off x="941832" y="2907792"/>
+            <a:ext cx="2157984" cy="256032"/>
+          </a:xfrm>
+          <a:prstGeom prst="rect">
+            <a:avLst/>
+          </a:prstGeom>
+          <a:noFill/>
+          <a:ln/>
+        </p:spPr>
+        <p:txBody>
+          <a:bodyPr wrap="square" lIns="0" tIns="0" rIns="0" bIns="0" rtlCol="0" anchor="ctr"/>
+          <a:lstStyle/>
+          <a:p>
+            <a:pPr indent="0" marL="0">
+              <a:buNone/>
+            </a:pPr>
+            <a:r>
+              <a:rPr lang="en-US" sz="1000" dirty="0">
+                <a:solidFill>
+                  <a:srgbClr val="74899A"/>
+                </a:solidFill>
+                <a:latin typeface="Calibri" pitchFamily="34" charset="0"/>
+                <a:ea typeface="Calibri" pitchFamily="34" charset="-122"/>
+                <a:cs typeface="Calibri" pitchFamily="34" charset="-120"/>
+              </a:rPr>
+              <a:t>sin tarjeta · sin límite</a:t>
+            </a:r>
+            <a:endParaRPr lang="en-US" sz="1000" dirty="0"/>
+          </a:p>
+        </p:txBody>
+      </p:sp>
+      <p:sp>
+        <p:nvSpPr>
+          <p:cNvPr id="10" name="Text 8"/>
+          <p:cNvSpPr/>
+          <p:nvPr/>
+        </p:nvSpPr>
+        <p:spPr>
+          <a:xfrm>
+            <a:off x="941832" y="3200400"/>
+            <a:ext cx="2157984" cy="960120"/>
+          </a:xfrm>
+          <a:prstGeom prst="rect">
+            <a:avLst/>
+          </a:prstGeom>
+          <a:noFill/>
+          <a:ln/>
+        </p:spPr>
+        <p:txBody>
+          <a:bodyPr wrap="square" lIns="0" tIns="0" rIns="0" bIns="0" rtlCol="0" anchor="t"/>
+          <a:lstStyle/>
+          <a:p>
+            <a:pPr marL="342900" indent="-342900">
+              <a:spcAft>
+                <a:spcPts val="300"/>
+              </a:spcAft>
+              <a:buSzPct val="100000"/>
+              <a:buChar char="•"/>
+            </a:pPr>
+            <a:r>
+              <a:rPr lang="en-US" sz="1050" dirty="0">
+                <a:solidFill>
+                  <a:srgbClr val="40566A"/>
+                </a:solidFill>
+                <a:latin typeface="Calibri" pitchFamily="34" charset="0"/>
+                <a:ea typeface="Calibri" pitchFamily="34" charset="-122"/>
+                <a:cs typeface="Calibri" pitchFamily="34" charset="-120"/>
+              </a:rPr>
+              <a:t>Hasta 8 residentes</a:t>
+            </a:r>
+            <a:endParaRPr lang="en-US" sz="1050" dirty="0"/>
+          </a:p>
+          <a:p>
+            <a:pPr marL="342900" indent="-342900">
+              <a:spcAft>
+                <a:spcPts val="300"/>
+              </a:spcAft>
+              <a:buSzPct val="100000"/>
+              <a:buChar char="•"/>
+            </a:pPr>
+            <a:r>
+              <a:rPr lang="en-US" sz="1050" dirty="0">
+                <a:solidFill>
+                  <a:srgbClr val="40566A"/>
+                </a:solidFill>
+                <a:latin typeface="Calibri" pitchFamily="34" charset="0"/>
+                <a:ea typeface="Calibri" pitchFamily="34" charset="-122"/>
+                <a:cs typeface="Calibri" pitchFamily="34" charset="-120"/>
+              </a:rPr>
+              <a:t>1 usuario activo</a:t>
+            </a:r>
+            <a:endParaRPr lang="en-US" sz="1050" dirty="0"/>
+          </a:p>
+          <a:p>
+            <a:pPr marL="342900" indent="-342900">
+              <a:spcAft>
+                <a:spcPts val="300"/>
+              </a:spcAft>
+              <a:buSzPct val="100000"/>
+              <a:buChar char="•"/>
+            </a:pPr>
+            <a:r>
+              <a:rPr lang="en-US" sz="1050" dirty="0">
+                <a:solidFill>
+                  <a:srgbClr val="40566A"/>
+                </a:solidFill>
+                <a:latin typeface="Calibri" pitchFamily="34" charset="0"/>
+                <a:ea typeface="Calibri" pitchFamily="34" charset="-122"/>
+                <a:cs typeface="Calibri" pitchFamily="34" charset="-120"/>
+              </a:rPr>
+              <a:t>Rondas básicas</a:t>
+            </a:r>
+            <a:endParaRPr lang="en-US" sz="1050" dirty="0"/>
+          </a:p>
+        </p:txBody>
+      </p:sp>
+      <p:sp>
+        <p:nvSpPr>
+          <p:cNvPr id="11" name="Shape 9"/>
+          <p:cNvSpPr/>
+          <p:nvPr/>
+        </p:nvSpPr>
+        <p:spPr>
+          <a:xfrm>
+            <a:off x="3502152" y="1920240"/>
+            <a:ext cx="2487168" cy="2377440"/>
+          </a:xfrm>
+          <a:prstGeom prst="roundRect">
+            <a:avLst>
+              <a:gd name="adj" fmla="val 3077"/>
             </a:avLst>
           </a:prstGeom>
           <a:solidFill>
@@ -10777,14 +11006,14 @@
       </p:sp>
       <p:sp>
         <p:nvSpPr>
-          <p:cNvPr id="7" name="Text 5"/>
-          <p:cNvSpPr/>
-          <p:nvPr/>
-        </p:nvSpPr>
-        <p:spPr>
-          <a:xfrm>
-            <a:off x="1033272" y="2121408"/>
-            <a:ext cx="2834640" cy="347472"/>
+          <p:cNvPr id="12" name="Text 10"/>
+          <p:cNvSpPr/>
+          <p:nvPr/>
+        </p:nvSpPr>
+        <p:spPr>
+          <a:xfrm>
+            <a:off x="3666744" y="2103120"/>
+            <a:ext cx="2157984" cy="347472"/>
           </a:xfrm>
           <a:prstGeom prst="rect">
             <a:avLst/>
@@ -10800,7 +11029,7 @@
               <a:buNone/>
             </a:pPr>
             <a:r>
-              <a:rPr lang="en-US" sz="1700" b="1" dirty="0">
+              <a:rPr lang="en-US" sz="1300" b="1" dirty="0">
                 <a:solidFill>
                   <a:srgbClr val="0D1B26"/>
                 </a:solidFill>
@@ -10810,20 +11039,20 @@
               </a:rPr>
               <a:t>Esencial</a:t>
             </a:r>
-            <a:endParaRPr lang="en-US" sz="1700" dirty="0"/>
-          </a:p>
-        </p:txBody>
-      </p:sp>
-      <p:sp>
-        <p:nvSpPr>
-          <p:cNvPr id="8" name="Text 6"/>
-          <p:cNvSpPr/>
-          <p:nvPr/>
-        </p:nvSpPr>
-        <p:spPr>
-          <a:xfrm>
-            <a:off x="1033272" y="2487168"/>
-            <a:ext cx="2834640" cy="292608"/>
+            <a:endParaRPr lang="en-US" sz="1300" dirty="0"/>
+          </a:p>
+        </p:txBody>
+      </p:sp>
+      <p:sp>
+        <p:nvSpPr>
+          <p:cNvPr id="13" name="Text 11"/>
+          <p:cNvSpPr/>
+          <p:nvPr/>
+        </p:nvSpPr>
+        <p:spPr>
+          <a:xfrm>
+            <a:off x="3666744" y="2468880"/>
+            <a:ext cx="2157984" cy="438912"/>
           </a:xfrm>
           <a:prstGeom prst="rect">
             <a:avLst/>
@@ -10839,7 +11068,7 @@
               <a:buNone/>
             </a:pPr>
             <a:r>
-              <a:rPr lang="en-US" sz="1250" b="1" dirty="0">
+              <a:rPr lang="en-US" sz="2400" b="1" dirty="0">
                 <a:solidFill>
                   <a:srgbClr val="8A5A00"/>
                 </a:solidFill>
@@ -10847,22 +11076,61 @@
                 <a:ea typeface="Calibri" pitchFamily="34" charset="-122"/>
                 <a:cs typeface="Calibri" pitchFamily="34" charset="-120"/>
               </a:rPr>
-              <a:t>[ precio ] / mes</a:t>
-            </a:r>
-            <a:endParaRPr lang="en-US" sz="1250" dirty="0"/>
-          </a:p>
-        </p:txBody>
-      </p:sp>
-      <p:sp>
-        <p:nvSpPr>
-          <p:cNvPr id="9" name="Text 7"/>
-          <p:cNvSpPr/>
-          <p:nvPr/>
-        </p:nvSpPr>
-        <p:spPr>
-          <a:xfrm>
-            <a:off x="1033272" y="2852928"/>
-            <a:ext cx="2834640" cy="1188720"/>
+              <a:t>$1,990</a:t>
+            </a:r>
+            <a:endParaRPr lang="en-US" sz="2400" dirty="0"/>
+          </a:p>
+        </p:txBody>
+      </p:sp>
+      <p:sp>
+        <p:nvSpPr>
+          <p:cNvPr id="14" name="Text 12"/>
+          <p:cNvSpPr/>
+          <p:nvPr/>
+        </p:nvSpPr>
+        <p:spPr>
+          <a:xfrm>
+            <a:off x="3666744" y="2907792"/>
+            <a:ext cx="2157984" cy="256032"/>
+          </a:xfrm>
+          <a:prstGeom prst="rect">
+            <a:avLst/>
+          </a:prstGeom>
+          <a:noFill/>
+          <a:ln/>
+        </p:spPr>
+        <p:txBody>
+          <a:bodyPr wrap="square" lIns="0" tIns="0" rIns="0" bIns="0" rtlCol="0" anchor="ctr"/>
+          <a:lstStyle/>
+          <a:p>
+            <a:pPr indent="0" marL="0">
+              <a:buNone/>
+            </a:pPr>
+            <a:r>
+              <a:rPr lang="en-US" sz="1000" dirty="0">
+                <a:solidFill>
+                  <a:srgbClr val="74899A"/>
+                </a:solidFill>
+                <a:latin typeface="Calibri" pitchFamily="34" charset="0"/>
+                <a:ea typeface="Calibri" pitchFamily="34" charset="-122"/>
+                <a:cs typeface="Calibri" pitchFamily="34" charset="-120"/>
+              </a:rPr>
+              <a:t>MXN / mes</a:t>
+            </a:r>
+            <a:endParaRPr lang="en-US" sz="1000" dirty="0"/>
+          </a:p>
+        </p:txBody>
+      </p:sp>
+      <p:sp>
+        <p:nvSpPr>
+          <p:cNvPr id="15" name="Text 13"/>
+          <p:cNvSpPr/>
+          <p:nvPr/>
+        </p:nvSpPr>
+        <p:spPr>
+          <a:xfrm>
+            <a:off x="3666744" y="3200400"/>
+            <a:ext cx="2157984" cy="960120"/>
           </a:xfrm>
           <a:prstGeom prst="rect">
             <a:avLst/>
@@ -10876,13 +11144,13 @@
           <a:p>
             <a:pPr marL="342900" indent="-342900">
               <a:spcAft>
-                <a:spcPts val="400"/>
+                <a:spcPts val="300"/>
               </a:spcAft>
               <a:buSzPct val="100000"/>
               <a:buChar char="•"/>
             </a:pPr>
             <a:r>
-              <a:rPr lang="en-US" sz="1150" dirty="0">
+              <a:rPr lang="en-US" sz="1050" dirty="0">
                 <a:solidFill>
                   <a:srgbClr val="40566A"/>
                 </a:solidFill>
@@ -10890,20 +11158,20 @@
                 <a:ea typeface="Calibri" pitchFamily="34" charset="-122"/>
                 <a:cs typeface="Calibri" pitchFamily="34" charset="-120"/>
               </a:rPr>
-              <a:t>Rondas y alertas</a:t>
-            </a:r>
-            <a:endParaRPr lang="en-US" sz="1150" dirty="0"/>
+              <a:t>Hasta 30 residentes</a:t>
+            </a:r>
+            <a:endParaRPr lang="en-US" sz="1050" dirty="0"/>
           </a:p>
           <a:p>
             <a:pPr marL="342900" indent="-342900">
               <a:spcAft>
-                <a:spcPts val="400"/>
+                <a:spcPts val="300"/>
               </a:spcAft>
               <a:buSzPct val="100000"/>
               <a:buChar char="•"/>
             </a:pPr>
             <a:r>
-              <a:rPr lang="en-US" sz="1150" dirty="0">
+              <a:rPr lang="en-US" sz="1050" dirty="0">
                 <a:solidFill>
                   <a:srgbClr val="40566A"/>
                 </a:solidFill>
@@ -10911,20 +11179,20 @@
                 <a:ea typeface="Calibri" pitchFamily="34" charset="-122"/>
                 <a:cs typeface="Calibri" pitchFamily="34" charset="-120"/>
               </a:rPr>
-              <a:t>Panel del supervisor</a:t>
-            </a:r>
-            <a:endParaRPr lang="en-US" sz="1150" dirty="0"/>
+              <a:t>3 usuarios · alertas</a:t>
+            </a:r>
+            <a:endParaRPr lang="en-US" sz="1050" dirty="0"/>
           </a:p>
           <a:p>
             <a:pPr marL="342900" indent="-342900">
               <a:spcAft>
-                <a:spcPts val="400"/>
+                <a:spcPts val="300"/>
               </a:spcAft>
               <a:buSzPct val="100000"/>
               <a:buChar char="•"/>
             </a:pPr>
             <a:r>
-              <a:rPr lang="en-US" sz="1150" dirty="0">
+              <a:rPr lang="en-US" sz="1050" dirty="0">
                 <a:solidFill>
                   <a:srgbClr val="40566A"/>
                 </a:solidFill>
@@ -10932,26 +11200,26 @@
                 <a:ea typeface="Calibri" pitchFamily="34" charset="-122"/>
                 <a:cs typeface="Calibri" pitchFamily="34" charset="-120"/>
               </a:rPr>
-              <a:t>Bitácora auditable</a:t>
-            </a:r>
-            <a:endParaRPr lang="en-US" sz="1150" dirty="0"/>
-          </a:p>
-        </p:txBody>
-      </p:sp>
-      <p:sp>
-        <p:nvSpPr>
-          <p:cNvPr id="10" name="Shape 8"/>
-          <p:cNvSpPr/>
-          <p:nvPr/>
-        </p:nvSpPr>
-        <p:spPr>
-          <a:xfrm>
-            <a:off x="4389120" y="1920240"/>
-            <a:ext cx="3337560" cy="2286000"/>
+              <a:t>Auditoría completa</a:t>
+            </a:r>
+            <a:endParaRPr lang="en-US" sz="1050" dirty="0"/>
+          </a:p>
+        </p:txBody>
+      </p:sp>
+      <p:sp>
+        <p:nvSpPr>
+          <p:cNvPr id="16" name="Shape 14"/>
+          <p:cNvSpPr/>
+          <p:nvPr/>
+        </p:nvSpPr>
+        <p:spPr>
+          <a:xfrm>
+            <a:off x="6227064" y="1920240"/>
+            <a:ext cx="2487168" cy="2377440"/>
           </a:xfrm>
           <a:prstGeom prst="roundRect">
             <a:avLst>
-              <a:gd name="adj" fmla="val 3200"/>
+              <a:gd name="adj" fmla="val 3077"/>
             </a:avLst>
           </a:prstGeom>
           <a:solidFill>
@@ -10967,14 +11235,14 @@
       </p:sp>
       <p:sp>
         <p:nvSpPr>
-          <p:cNvPr id="11" name="Text 9"/>
-          <p:cNvSpPr/>
-          <p:nvPr/>
-        </p:nvSpPr>
-        <p:spPr>
-          <a:xfrm>
-            <a:off x="4645152" y="2121408"/>
-            <a:ext cx="2834640" cy="347472"/>
+          <p:cNvPr id="17" name="Text 15"/>
+          <p:cNvSpPr/>
+          <p:nvPr/>
+        </p:nvSpPr>
+        <p:spPr>
+          <a:xfrm>
+            <a:off x="6391656" y="2103120"/>
+            <a:ext cx="2157984" cy="347472"/>
           </a:xfrm>
           <a:prstGeom prst="rect">
             <a:avLst/>
@@ -10990,7 +11258,7 @@
               <a:buNone/>
             </a:pPr>
             <a:r>
-              <a:rPr lang="en-US" sz="1700" b="1" dirty="0">
+              <a:rPr lang="en-US" sz="1300" b="1" dirty="0">
                 <a:solidFill>
                   <a:srgbClr val="0A3D5C"/>
                 </a:solidFill>
@@ -10998,22 +11266,22 @@
                 <a:ea typeface="Calibri" pitchFamily="34" charset="-122"/>
                 <a:cs typeface="Calibri" pitchFamily="34" charset="-120"/>
               </a:rPr>
-              <a:t>Profesional</a:t>
-            </a:r>
-            <a:endParaRPr lang="en-US" sz="1700" dirty="0"/>
-          </a:p>
-        </p:txBody>
-      </p:sp>
-      <p:sp>
-        <p:nvSpPr>
-          <p:cNvPr id="12" name="Text 10"/>
-          <p:cNvSpPr/>
-          <p:nvPr/>
-        </p:nvSpPr>
-        <p:spPr>
-          <a:xfrm>
-            <a:off x="4645152" y="2487168"/>
-            <a:ext cx="2834640" cy="292608"/>
+              <a:t>Profesional ⭐</a:t>
+            </a:r>
+            <a:endParaRPr lang="en-US" sz="1300" dirty="0"/>
+          </a:p>
+        </p:txBody>
+      </p:sp>
+      <p:sp>
+        <p:nvSpPr>
+          <p:cNvPr id="18" name="Text 16"/>
+          <p:cNvSpPr/>
+          <p:nvPr/>
+        </p:nvSpPr>
+        <p:spPr>
+          <a:xfrm>
+            <a:off x="6391656" y="2468880"/>
+            <a:ext cx="2157984" cy="438912"/>
           </a:xfrm>
           <a:prstGeom prst="rect">
             <a:avLst/>
@@ -11029,30 +11297,69 @@
               <a:buNone/>
             </a:pPr>
             <a:r>
-              <a:rPr lang="en-US" sz="1250" b="1" dirty="0">
-                <a:solidFill>
-                  <a:srgbClr val="8A5A00"/>
-                </a:solidFill>
-                <a:latin typeface="Calibri" pitchFamily="34" charset="0"/>
-                <a:ea typeface="Calibri" pitchFamily="34" charset="-122"/>
-                <a:cs typeface="Calibri" pitchFamily="34" charset="-120"/>
-              </a:rPr>
-              <a:t>[ precio ] / mes</a:t>
-            </a:r>
-            <a:endParaRPr lang="en-US" sz="1250" dirty="0"/>
-          </a:p>
-        </p:txBody>
-      </p:sp>
-      <p:sp>
-        <p:nvSpPr>
-          <p:cNvPr id="13" name="Text 11"/>
-          <p:cNvSpPr/>
-          <p:nvPr/>
-        </p:nvSpPr>
-        <p:spPr>
-          <a:xfrm>
-            <a:off x="4645152" y="2852928"/>
-            <a:ext cx="2834640" cy="1188720"/>
+              <a:rPr lang="en-US" sz="2400" b="1" dirty="0">
+                <a:solidFill>
+                  <a:srgbClr val="0A3D5C"/>
+                </a:solidFill>
+                <a:latin typeface="Calibri" pitchFamily="34" charset="0"/>
+                <a:ea typeface="Calibri" pitchFamily="34" charset="-122"/>
+                <a:cs typeface="Calibri" pitchFamily="34" charset="-120"/>
+              </a:rPr>
+              <a:t>$3,990</a:t>
+            </a:r>
+            <a:endParaRPr lang="en-US" sz="2400" dirty="0"/>
+          </a:p>
+        </p:txBody>
+      </p:sp>
+      <p:sp>
+        <p:nvSpPr>
+          <p:cNvPr id="19" name="Text 17"/>
+          <p:cNvSpPr/>
+          <p:nvPr/>
+        </p:nvSpPr>
+        <p:spPr>
+          <a:xfrm>
+            <a:off x="6391656" y="2907792"/>
+            <a:ext cx="2157984" cy="256032"/>
+          </a:xfrm>
+          <a:prstGeom prst="rect">
+            <a:avLst/>
+          </a:prstGeom>
+          <a:noFill/>
+          <a:ln/>
+        </p:spPr>
+        <p:txBody>
+          <a:bodyPr wrap="square" lIns="0" tIns="0" rIns="0" bIns="0" rtlCol="0" anchor="ctr"/>
+          <a:lstStyle/>
+          <a:p>
+            <a:pPr indent="0" marL="0">
+              <a:buNone/>
+            </a:pPr>
+            <a:r>
+              <a:rPr lang="en-US" sz="1000" dirty="0">
+                <a:solidFill>
+                  <a:srgbClr val="74899A"/>
+                </a:solidFill>
+                <a:latin typeface="Calibri" pitchFamily="34" charset="0"/>
+                <a:ea typeface="Calibri" pitchFamily="34" charset="-122"/>
+                <a:cs typeface="Calibri" pitchFamily="34" charset="-120"/>
+              </a:rPr>
+              <a:t>MXN / mes · sweet spot</a:t>
+            </a:r>
+            <a:endParaRPr lang="en-US" sz="1000" dirty="0"/>
+          </a:p>
+        </p:txBody>
+      </p:sp>
+      <p:sp>
+        <p:nvSpPr>
+          <p:cNvPr id="20" name="Text 18"/>
+          <p:cNvSpPr/>
+          <p:nvPr/>
+        </p:nvSpPr>
+        <p:spPr>
+          <a:xfrm>
+            <a:off x="6391656" y="3200400"/>
+            <a:ext cx="2157984" cy="960120"/>
           </a:xfrm>
           <a:prstGeom prst="rect">
             <a:avLst/>
@@ -11066,13 +11373,13 @@
           <a:p>
             <a:pPr marL="342900" indent="-342900">
               <a:spcAft>
-                <a:spcPts val="400"/>
+                <a:spcPts val="300"/>
               </a:spcAft>
               <a:buSzPct val="100000"/>
               <a:buChar char="•"/>
             </a:pPr>
             <a:r>
-              <a:rPr lang="en-US" sz="1150" dirty="0">
+              <a:rPr lang="en-US" sz="1050" dirty="0">
                 <a:solidFill>
                   <a:srgbClr val="40566A"/>
                 </a:solidFill>
@@ -11080,20 +11387,20 @@
                 <a:ea typeface="Calibri" pitchFamily="34" charset="-122"/>
                 <a:cs typeface="Calibri" pitchFamily="34" charset="-120"/>
               </a:rPr>
-              <a:t>Todo lo de Esencial</a:t>
-            </a:r>
-            <a:endParaRPr lang="en-US" sz="1150" dirty="0"/>
+              <a:t>Hasta 80 residentes</a:t>
+            </a:r>
+            <a:endParaRPr lang="en-US" sz="1050" dirty="0"/>
           </a:p>
           <a:p>
             <a:pPr marL="342900" indent="-342900">
               <a:spcAft>
-                <a:spcPts val="400"/>
+                <a:spcPts val="300"/>
               </a:spcAft>
               <a:buSzPct val="100000"/>
               <a:buChar char="•"/>
             </a:pPr>
             <a:r>
-              <a:rPr lang="en-US" sz="1150" dirty="0">
+              <a:rPr lang="en-US" sz="1050" dirty="0">
                 <a:solidFill>
                   <a:srgbClr val="40566A"/>
                 </a:solidFill>
@@ -11101,20 +11408,20 @@
                 <a:ea typeface="Calibri" pitchFamily="34" charset="-122"/>
                 <a:cs typeface="Calibri" pitchFamily="34" charset="-120"/>
               </a:rPr>
-              <a:t>Reportes de turno</a:t>
-            </a:r>
-            <a:endParaRPr lang="en-US" sz="1150" dirty="0"/>
+              <a:t>10 usuarios · dashboard</a:t>
+            </a:r>
+            <a:endParaRPr lang="en-US" sz="1050" dirty="0"/>
           </a:p>
           <a:p>
             <a:pPr marL="342900" indent="-342900">
               <a:spcAft>
-                <a:spcPts val="400"/>
+                <a:spcPts val="300"/>
               </a:spcAft>
               <a:buSzPct val="100000"/>
               <a:buChar char="•"/>
             </a:pPr>
             <a:r>
-              <a:rPr lang="en-US" sz="1150" dirty="0">
+              <a:rPr lang="en-US" sz="1050" dirty="0">
                 <a:solidFill>
                   <a:srgbClr val="40566A"/>
                 </a:solidFill>
@@ -11122,26 +11429,26 @@
                 <a:ea typeface="Calibri" pitchFamily="34" charset="-122"/>
                 <a:cs typeface="Calibri" pitchFamily="34" charset="-120"/>
               </a:rPr>
-              <a:t>Filtros y métricas</a:t>
-            </a:r>
-            <a:endParaRPr lang="en-US" sz="1150" dirty="0"/>
-          </a:p>
-        </p:txBody>
-      </p:sp>
-      <p:sp>
-        <p:nvSpPr>
-          <p:cNvPr id="14" name="Shape 12"/>
-          <p:cNvSpPr/>
-          <p:nvPr/>
-        </p:nvSpPr>
-        <p:spPr>
-          <a:xfrm>
-            <a:off x="8001000" y="1920240"/>
-            <a:ext cx="3337560" cy="2286000"/>
+              <a:t>Soporte prioritario</a:t>
+            </a:r>
+            <a:endParaRPr lang="en-US" sz="1050" dirty="0"/>
+          </a:p>
+        </p:txBody>
+      </p:sp>
+      <p:sp>
+        <p:nvSpPr>
+          <p:cNvPr id="21" name="Shape 19"/>
+          <p:cNvSpPr/>
+          <p:nvPr/>
+        </p:nvSpPr>
+        <p:spPr>
+          <a:xfrm>
+            <a:off x="8951976" y="1920240"/>
+            <a:ext cx="2487168" cy="2377440"/>
           </a:xfrm>
           <a:prstGeom prst="roundRect">
             <a:avLst>
-              <a:gd name="adj" fmla="val 3200"/>
+              <a:gd name="adj" fmla="val 3077"/>
             </a:avLst>
           </a:prstGeom>
           <a:solidFill>
@@ -11157,14 +11464,14 @@
       </p:sp>
       <p:sp>
         <p:nvSpPr>
-          <p:cNvPr id="15" name="Text 13"/>
-          <p:cNvSpPr/>
-          <p:nvPr/>
-        </p:nvSpPr>
-        <p:spPr>
-          <a:xfrm>
-            <a:off x="8257032" y="2121408"/>
-            <a:ext cx="2834640" cy="347472"/>
+          <p:cNvPr id="22" name="Text 20"/>
+          <p:cNvSpPr/>
+          <p:nvPr/>
+        </p:nvSpPr>
+        <p:spPr>
+          <a:xfrm>
+            <a:off x="9116568" y="2103120"/>
+            <a:ext cx="2157984" cy="347472"/>
           </a:xfrm>
           <a:prstGeom prst="rect">
             <a:avLst/>
@@ -11180,7 +11487,7 @@
               <a:buNone/>
             </a:pPr>
             <a:r>
-              <a:rPr lang="en-US" sz="1700" b="1" dirty="0">
+              <a:rPr lang="en-US" sz="1300" b="1" dirty="0">
                 <a:solidFill>
                   <a:srgbClr val="0D1B26"/>
                 </a:solidFill>
@@ -11190,20 +11497,20 @@
               </a:rPr>
               <a:t>Institucional</a:t>
             </a:r>
-            <a:endParaRPr lang="en-US" sz="1700" dirty="0"/>
-          </a:p>
-        </p:txBody>
-      </p:sp>
-      <p:sp>
-        <p:nvSpPr>
-          <p:cNvPr id="16" name="Text 14"/>
-          <p:cNvSpPr/>
-          <p:nvPr/>
-        </p:nvSpPr>
-        <p:spPr>
-          <a:xfrm>
-            <a:off x="8257032" y="2487168"/>
-            <a:ext cx="2834640" cy="292608"/>
+            <a:endParaRPr lang="en-US" sz="1300" dirty="0"/>
+          </a:p>
+        </p:txBody>
+      </p:sp>
+      <p:sp>
+        <p:nvSpPr>
+          <p:cNvPr id="23" name="Text 21"/>
+          <p:cNvSpPr/>
+          <p:nvPr/>
+        </p:nvSpPr>
+        <p:spPr>
+          <a:xfrm>
+            <a:off x="9116568" y="2468880"/>
+            <a:ext cx="2157984" cy="438912"/>
           </a:xfrm>
           <a:prstGeom prst="rect">
             <a:avLst/>
@@ -11219,7 +11526,7 @@
               <a:buNone/>
             </a:pPr>
             <a:r>
-              <a:rPr lang="en-US" sz="1250" b="1" dirty="0">
+              <a:rPr lang="en-US" sz="2400" b="1" dirty="0">
                 <a:solidFill>
                   <a:srgbClr val="8A5A00"/>
                 </a:solidFill>
@@ -11227,22 +11534,61 @@
                 <a:ea typeface="Calibri" pitchFamily="34" charset="-122"/>
                 <a:cs typeface="Calibri" pitchFamily="34" charset="-120"/>
               </a:rPr>
-              <a:t>[ precio ] / mes</a:t>
-            </a:r>
-            <a:endParaRPr lang="en-US" sz="1250" dirty="0"/>
-          </a:p>
-        </p:txBody>
-      </p:sp>
-      <p:sp>
-        <p:nvSpPr>
-          <p:cNvPr id="17" name="Text 15"/>
-          <p:cNvSpPr/>
-          <p:nvPr/>
-        </p:nvSpPr>
-        <p:spPr>
-          <a:xfrm>
-            <a:off x="8257032" y="2852928"/>
-            <a:ext cx="2834640" cy="1188720"/>
+              <a:t>$8,490</a:t>
+            </a:r>
+            <a:endParaRPr lang="en-US" sz="2400" dirty="0"/>
+          </a:p>
+        </p:txBody>
+      </p:sp>
+      <p:sp>
+        <p:nvSpPr>
+          <p:cNvPr id="24" name="Text 22"/>
+          <p:cNvSpPr/>
+          <p:nvPr/>
+        </p:nvSpPr>
+        <p:spPr>
+          <a:xfrm>
+            <a:off x="9116568" y="2907792"/>
+            <a:ext cx="2157984" cy="256032"/>
+          </a:xfrm>
+          <a:prstGeom prst="rect">
+            <a:avLst/>
+          </a:prstGeom>
+          <a:noFill/>
+          <a:ln/>
+        </p:spPr>
+        <p:txBody>
+          <a:bodyPr wrap="square" lIns="0" tIns="0" rIns="0" bIns="0" rtlCol="0" anchor="ctr"/>
+          <a:lstStyle/>
+          <a:p>
+            <a:pPr indent="0" marL="0">
+              <a:buNone/>
+            </a:pPr>
+            <a:r>
+              <a:rPr lang="en-US" sz="1000" dirty="0">
+                <a:solidFill>
+                  <a:srgbClr val="74899A"/>
+                </a:solidFill>
+                <a:latin typeface="Calibri" pitchFamily="34" charset="0"/>
+                <a:ea typeface="Calibri" pitchFamily="34" charset="-122"/>
+                <a:cs typeface="Calibri" pitchFamily="34" charset="-120"/>
+              </a:rPr>
+              <a:t>MXN / mes</a:t>
+            </a:r>
+            <a:endParaRPr lang="en-US" sz="1000" dirty="0"/>
+          </a:p>
+        </p:txBody>
+      </p:sp>
+      <p:sp>
+        <p:nvSpPr>
+          <p:cNvPr id="25" name="Text 23"/>
+          <p:cNvSpPr/>
+          <p:nvPr/>
+        </p:nvSpPr>
+        <p:spPr>
+          <a:xfrm>
+            <a:off x="9116568" y="3200400"/>
+            <a:ext cx="2157984" cy="960120"/>
           </a:xfrm>
           <a:prstGeom prst="rect">
             <a:avLst/>
@@ -11256,13 +11602,13 @@
           <a:p>
             <a:pPr marL="342900" indent="-342900">
               <a:spcAft>
-                <a:spcPts val="400"/>
+                <a:spcPts val="300"/>
               </a:spcAft>
               <a:buSzPct val="100000"/>
               <a:buChar char="•"/>
             </a:pPr>
             <a:r>
-              <a:rPr lang="en-US" sz="1150" dirty="0">
+              <a:rPr lang="en-US" sz="1050" dirty="0">
                 <a:solidFill>
                   <a:srgbClr val="40566A"/>
                 </a:solidFill>
@@ -11270,20 +11616,20 @@
                 <a:ea typeface="Calibri" pitchFamily="34" charset="-122"/>
                 <a:cs typeface="Calibri" pitchFamily="34" charset="-120"/>
               </a:rPr>
-              <a:t>Multi-residencia</a:t>
-            </a:r>
-            <a:endParaRPr lang="en-US" sz="1150" dirty="0"/>
+              <a:t>Sin límite · multi-sede</a:t>
+            </a:r>
+            <a:endParaRPr lang="en-US" sz="1050" dirty="0"/>
           </a:p>
           <a:p>
             <a:pPr marL="342900" indent="-342900">
               <a:spcAft>
-                <a:spcPts val="400"/>
+                <a:spcPts val="300"/>
               </a:spcAft>
               <a:buSzPct val="100000"/>
               <a:buChar char="•"/>
             </a:pPr>
             <a:r>
-              <a:rPr lang="en-US" sz="1150" dirty="0">
+              <a:rPr lang="en-US" sz="1050" dirty="0">
                 <a:solidFill>
                   <a:srgbClr val="40566A"/>
                 </a:solidFill>
@@ -11291,19 +11637,58 @@
                 <a:ea typeface="Calibri" pitchFamily="34" charset="-122"/>
                 <a:cs typeface="Calibri" pitchFamily="34" charset="-120"/>
               </a:rPr>
-              <a:t>Onboarding dedicado</a:t>
-            </a:r>
-            <a:endParaRPr lang="en-US" sz="1150" dirty="0"/>
+              <a:t>SLA + soporte dedicado</a:t>
+            </a:r>
+            <a:endParaRPr lang="en-US" sz="1050" dirty="0"/>
           </a:p>
           <a:p>
             <a:pPr marL="342900" indent="-342900">
               <a:spcAft>
-                <a:spcPts val="400"/>
+                <a:spcPts val="300"/>
               </a:spcAft>
               <a:buSzPct val="100000"/>
               <a:buChar char="•"/>
             </a:pPr>
             <a:r>
+              <a:rPr lang="en-US" sz="1050" dirty="0">
+                <a:solidFill>
+                  <a:srgbClr val="40566A"/>
+                </a:solidFill>
+                <a:latin typeface="Calibri" pitchFamily="34" charset="0"/>
+                <a:ea typeface="Calibri" pitchFamily="34" charset="-122"/>
+                <a:cs typeface="Calibri" pitchFamily="34" charset="-120"/>
+              </a:rPr>
+              <a:t>Onboarding incluido</a:t>
+            </a:r>
+            <a:endParaRPr lang="en-US" sz="1050" dirty="0"/>
+          </a:p>
+        </p:txBody>
+      </p:sp>
+      <p:sp>
+        <p:nvSpPr>
+          <p:cNvPr id="26" name="Text 24"/>
+          <p:cNvSpPr/>
+          <p:nvPr/>
+        </p:nvSpPr>
+        <p:spPr>
+          <a:xfrm>
+            <a:off x="777240" y="4462272"/>
+            <a:ext cx="10607040" cy="320040"/>
+          </a:xfrm>
+          <a:prstGeom prst="rect">
+            <a:avLst/>
+          </a:prstGeom>
+          <a:noFill/>
+          <a:ln/>
+        </p:spPr>
+        <p:txBody>
+          <a:bodyPr wrap="square" lIns="0" tIns="0" rIns="0" bIns="0" rtlCol="0" anchor="ctr"/>
+          <a:lstStyle/>
+          <a:p>
+            <a:pPr indent="0" marL="0">
+              <a:buNone/>
+            </a:pPr>
+            <a:r>
               <a:rPr lang="en-US" sz="1150" dirty="0">
                 <a:solidFill>
                   <a:srgbClr val="40566A"/>
@@ -11312,112 +11697,7 @@
                 <a:ea typeface="Calibri" pitchFamily="34" charset="-122"/>
                 <a:cs typeface="Calibri" pitchFamily="34" charset="-120"/>
               </a:rPr>
-              <a:t>Acuerdo de servicio</a:t>
-            </a:r>
-            <a:endParaRPr lang="en-US" sz="1150" dirty="0"/>
-          </a:p>
-        </p:txBody>
-      </p:sp>
-      <p:sp>
-        <p:nvSpPr>
-          <p:cNvPr id="18" name="Text 16"/>
-          <p:cNvSpPr/>
-          <p:nvPr/>
-        </p:nvSpPr>
-        <p:spPr>
-          <a:xfrm>
-            <a:off x="777240" y="4389120"/>
-            <a:ext cx="10607040" cy="365760"/>
-          </a:xfrm>
-          <a:prstGeom prst="rect">
-            <a:avLst/>
-          </a:prstGeom>
-          <a:noFill/>
-          <a:ln/>
-        </p:spPr>
-        <p:txBody>
-          <a:bodyPr wrap="square" lIns="0" tIns="0" rIns="0" bIns="0" rtlCol="0" anchor="ctr"/>
-          <a:lstStyle/>
-          <a:p>
-            <a:pPr indent="0" marL="0">
-              <a:buNone/>
-            </a:pPr>
-            <a:r>
-              <a:rPr lang="en-US" sz="1250" dirty="0">
-                <a:solidFill>
-                  <a:srgbClr val="40566A"/>
-                </a:solidFill>
-                <a:latin typeface="Calibri" pitchFamily="34" charset="0"/>
-                <a:ea typeface="Calibri" pitchFamily="34" charset="-122"/>
-                <a:cs typeface="Calibri" pitchFamily="34" charset="-120"/>
-              </a:rPr>
-              <a:t>Sin costo de hardware ni instalación. La migración parte del esquema actual del cliente: papel u hoja de cálculo.</a:t>
-            </a:r>
-            <a:endParaRPr lang="en-US" sz="1250" dirty="0"/>
-          </a:p>
-        </p:txBody>
-      </p:sp>
-      <p:sp>
-        <p:nvSpPr>
-          <p:cNvPr id="19" name="Shape 17"/>
-          <p:cNvSpPr/>
-          <p:nvPr/>
-        </p:nvSpPr>
-        <p:spPr>
-          <a:xfrm>
-            <a:off x="777240" y="5486400"/>
-            <a:ext cx="10607040" cy="566928"/>
-          </a:xfrm>
-          <a:prstGeom prst="roundRect">
-            <a:avLst>
-              <a:gd name="adj" fmla="val 9677"/>
-            </a:avLst>
-          </a:prstGeom>
-          <a:solidFill>
-            <a:srgbClr val="FDF3DD"/>
-          </a:solidFill>
-          <a:ln w="9525">
-            <a:solidFill>
-              <a:srgbClr val="D9B566"/>
-            </a:solidFill>
-            <a:prstDash val="solid"/>
-          </a:ln>
-        </p:spPr>
-      </p:sp>
-      <p:sp>
-        <p:nvSpPr>
-          <p:cNvPr id="20" name="Text 18"/>
-          <p:cNvSpPr/>
-          <p:nvPr/>
-        </p:nvSpPr>
-        <p:spPr>
-          <a:xfrm>
-            <a:off x="1005840" y="5486400"/>
-            <a:ext cx="10149840" cy="566928"/>
-          </a:xfrm>
-          <a:prstGeom prst="rect">
-            <a:avLst/>
-          </a:prstGeom>
-          <a:noFill/>
-          <a:ln/>
-        </p:spPr>
-        <p:txBody>
-          <a:bodyPr wrap="square" lIns="0" tIns="0" rIns="0" bIns="0" rtlCol="0" anchor="ctr"/>
-          <a:lstStyle/>
-          <a:p>
-            <a:pPr indent="0" marL="0">
-              <a:buNone/>
-            </a:pPr>
-            <a:r>
-              <a:rPr lang="en-US" sz="1150" b="1" dirty="0">
-                <a:solidFill>
-                  <a:srgbClr val="8A5A00"/>
-                </a:solidFill>
-                <a:latin typeface="Calibri" pitchFamily="34" charset="0"/>
-                <a:ea typeface="Calibri" pitchFamily="34" charset="-122"/>
-                <a:cs typeface="Calibri" pitchFamily="34" charset="-120"/>
-              </a:rPr>
-              <a:t>PENDIENTE — Definir los montos de cada plan y la unidad de cobro (por residencia o por plaza). Es la lámina que un fondo examina con más cuidado.</a:t>
+              <a:t>Freemium $0 elimina fricción de entrada y reduce CAC · Breakeven con 21 clientes Profesional · Flywheel B2C → leads B2B</a:t>
             </a:r>
             <a:endParaRPr lang="en-US" sz="1150" dirty="0"/>
           </a:p>

</xml_diff>